<commit_message>
Fix layout issues found in visual QA of investor deck PPTX
- Add breathing room between the title slide's headline and lead paragraph
- Recolor bullet dots with a two-run workaround (pptxgenjs 4.0.1 drops
  bullet.color silently)
- Replace the top accent-stripe on architecture cards with a small dot icon
- Show two-decimal values on the base-forecast chart's data labels
- Fix overlapping two-column legend on the investment-ask slide
</commit_message>
<xml_diff>
--- a/project-docs/INVESTOR_DECK.pptx
+++ b/project-docs/INVESTOR_DECK.pptx
@@ -694,7 +694,7 @@
           </c:spPr>
           <c:invertIfNegative val="0"/>
           <c:dLbls>
-            <c:numFmt formatCode="#,##0" sourceLinked="0"/>
+            <c:numFmt formatCode="0.00" sourceLinked="0"/>
             <c:txPr>
               <a:bodyPr/>
               <a:lstStyle/>
@@ -777,7 +777,7 @@
           </c:spPr>
           <c:invertIfNegative val="0"/>
           <c:dLbls>
-            <c:numFmt formatCode="#,##0" sourceLinked="0"/>
+            <c:numFmt formatCode="0.00" sourceLinked="0"/>
             <c:txPr>
               <a:bodyPr/>
               <a:lstStyle/>
@@ -860,7 +860,7 @@
           </c:spPr>
           <c:invertIfNegative val="0"/>
           <c:dLbls>
-            <c:numFmt formatCode="#,##0" sourceLinked="0"/>
+            <c:numFmt formatCode="0.00" sourceLinked="0"/>
             <c:txPr>
               <a:bodyPr/>
               <a:lstStyle/>
@@ -922,7 +922,7 @@
           </c:val>
         </c:ser>
         <c:dLbls>
-          <c:numFmt formatCode="#,##0" sourceLinked="0"/>
+          <c:numFmt formatCode="0.00" sourceLinked="0"/>
           <c:txPr>
             <a:bodyPr/>
             <a:lstStyle/>
@@ -3863,7 +3863,7 @@
         </p:nvSpPr>
         <p:spPr>
           <a:xfrm>
-            <a:off x="0" y="1828800"/>
+            <a:off x="0" y="1417320"/>
             <a:ext cx="12191695" cy="320040"/>
           </a:xfrm>
           <a:prstGeom prst="rect">
@@ -3902,8 +3902,8 @@
         </p:nvSpPr>
         <p:spPr>
           <a:xfrm>
-            <a:off x="1280160" y="2286000"/>
-            <a:ext cx="9628632" cy="1737360"/>
+            <a:off x="1280160" y="1828800"/>
+            <a:ext cx="9628632" cy="1965960"/>
           </a:xfrm>
           <a:prstGeom prst="rect">
             <a:avLst/>
@@ -3912,17 +3912,17 @@
           <a:ln/>
         </p:spPr>
         <p:txBody>
-          <a:bodyPr wrap="square" lIns="0" tIns="0" rIns="0" bIns="0" rtlCol="0" anchor="ctr"/>
+          <a:bodyPr wrap="square" lIns="0" tIns="0" rIns="0" bIns="0" rtlCol="0" anchor="t"/>
           <a:lstStyle/>
           <a:p>
             <a:pPr algn="ctr" indent="0" marL="0">
               <a:lnSpc>
-                <a:spcPct val="102000"/>
+                <a:spcPct val="105000"/>
               </a:lnSpc>
               <a:buNone/>
             </a:pPr>
             <a:r>
-              <a:rPr lang="en-US" sz="4000" b="1" dirty="0">
+              <a:rPr lang="en-US" sz="3600" b="1" dirty="0">
                 <a:solidFill>
                   <a:srgbClr val="F4F7FB"/>
                 </a:solidFill>
@@ -3932,7 +3932,7 @@
               </a:rPr>
               <a:t>Satu API untuk object storage yang tidak lagi terikat satu provider.</a:t>
             </a:r>
-            <a:endParaRPr lang="en-US" sz="4000" dirty="0"/>
+            <a:endParaRPr lang="en-US" sz="3600" dirty="0"/>
           </a:p>
         </p:txBody>
       </p:sp>
@@ -3944,7 +3944,7 @@
         </p:nvSpPr>
         <p:spPr>
           <a:xfrm>
-            <a:off x="2194560" y="3977640"/>
+            <a:off x="2194560" y="4160520"/>
             <a:ext cx="7799832" cy="777240"/>
           </a:xfrm>
           <a:prstGeom prst="rect">
@@ -3986,7 +3986,7 @@
         </p:nvSpPr>
         <p:spPr>
           <a:xfrm>
-            <a:off x="1432408" y="4892040"/>
+            <a:off x="1432408" y="5166360"/>
             <a:ext cx="1463040" cy="310896"/>
           </a:xfrm>
           <a:prstGeom prst="roundRect">
@@ -4010,7 +4010,7 @@
         </p:nvSpPr>
         <p:spPr>
           <a:xfrm>
-            <a:off x="1432408" y="4892040"/>
+            <a:off x="1432408" y="5166360"/>
             <a:ext cx="1463040" cy="310896"/>
           </a:xfrm>
           <a:prstGeom prst="rect">
@@ -4049,7 +4049,7 @@
         </p:nvSpPr>
         <p:spPr>
           <a:xfrm>
-            <a:off x="3169768" y="4892040"/>
+            <a:off x="3169768" y="5166360"/>
             <a:ext cx="2468880" cy="310896"/>
           </a:xfrm>
           <a:prstGeom prst="rect">
@@ -4088,7 +4088,7 @@
         </p:nvSpPr>
         <p:spPr>
           <a:xfrm>
-            <a:off x="5821528" y="4892040"/>
+            <a:off x="5821528" y="5166360"/>
             <a:ext cx="2468880" cy="310896"/>
           </a:xfrm>
           <a:prstGeom prst="rect">
@@ -7038,15 +7038,31 @@
           <a:bodyPr wrap="square" lIns="0" tIns="0" rIns="0" bIns="0" rtlCol="0" anchor="t"/>
           <a:lstStyle/>
           <a:p>
-            <a:pPr marL="228600" indent="-228600">
+            <a:pPr indent="0" marL="0">
+              <a:lnSpc>
+                <a:spcPct val="120000"/>
+              </a:lnSpc>
+              <a:buNone/>
+            </a:pPr>
+            <a:r>
+              <a:rPr lang="en-US" sz="1250" dirty="0">
+                <a:solidFill>
+                  <a:srgbClr val="FFB25B"/>
+                </a:solidFill>
+                <a:latin typeface="Calibri" pitchFamily="34" charset="0"/>
+                <a:ea typeface="Calibri" pitchFamily="34" charset="-122"/>
+                <a:cs typeface="Calibri" pitchFamily="34" charset="-120"/>
+              </a:rPr>
+              <a:t>●  </a:t>
+            </a:r>
+            <a:pPr indent="0" marL="0">
               <a:lnSpc>
                 <a:spcPct val="120000"/>
               </a:lnSpc>
               <a:spcAft>
                 <a:spcPts val="1000"/>
               </a:spcAft>
-              <a:buSzPct val="100000"/>
-              <a:buChar char="●"/>
+              <a:buNone/>
             </a:pPr>
             <a:r>
               <a:rPr lang="en-US" sz="1250" dirty="0">
@@ -7062,15 +7078,31 @@
             <a:endParaRPr lang="en-US" sz="1250" dirty="0"/>
           </a:p>
           <a:p>
-            <a:pPr marL="228600" indent="-228600">
+            <a:pPr indent="0" marL="0">
+              <a:lnSpc>
+                <a:spcPct val="120000"/>
+              </a:lnSpc>
+              <a:buNone/>
+            </a:pPr>
+            <a:r>
+              <a:rPr lang="en-US" sz="1250" dirty="0">
+                <a:solidFill>
+                  <a:srgbClr val="FFB25B"/>
+                </a:solidFill>
+                <a:latin typeface="Calibri" pitchFamily="34" charset="0"/>
+                <a:ea typeface="Calibri" pitchFamily="34" charset="-122"/>
+                <a:cs typeface="Calibri" pitchFamily="34" charset="-120"/>
+              </a:rPr>
+              <a:t>●  </a:t>
+            </a:r>
+            <a:pPr indent="0" marL="0">
               <a:lnSpc>
                 <a:spcPct val="120000"/>
               </a:lnSpc>
               <a:spcAft>
                 <a:spcPts val="1000"/>
               </a:spcAft>
-              <a:buSzPct val="100000"/>
-              <a:buChar char="●"/>
+              <a:buNone/>
             </a:pPr>
             <a:r>
               <a:rPr lang="en-US" sz="1250" dirty="0">
@@ -7086,15 +7118,31 @@
             <a:endParaRPr lang="en-US" sz="1250" dirty="0"/>
           </a:p>
           <a:p>
-            <a:pPr marL="228600" indent="-228600">
+            <a:pPr indent="0" marL="0">
+              <a:lnSpc>
+                <a:spcPct val="120000"/>
+              </a:lnSpc>
+              <a:buNone/>
+            </a:pPr>
+            <a:r>
+              <a:rPr lang="en-US" sz="1250" dirty="0">
+                <a:solidFill>
+                  <a:srgbClr val="FFB25B"/>
+                </a:solidFill>
+                <a:latin typeface="Calibri" pitchFamily="34" charset="0"/>
+                <a:ea typeface="Calibri" pitchFamily="34" charset="-122"/>
+                <a:cs typeface="Calibri" pitchFamily="34" charset="-120"/>
+              </a:rPr>
+              <a:t>●  </a:t>
+            </a:r>
+            <a:pPr indent="0" marL="0">
               <a:lnSpc>
                 <a:spcPct val="120000"/>
               </a:lnSpc>
               <a:spcAft>
                 <a:spcPts val="1000"/>
               </a:spcAft>
-              <a:buSzPct val="100000"/>
-              <a:buChar char="●"/>
+              <a:buNone/>
             </a:pPr>
             <a:r>
               <a:rPr lang="en-US" sz="1250" dirty="0">
@@ -12631,7 +12679,7 @@
         </p:nvSpPr>
         <p:spPr>
           <a:xfrm>
-            <a:off x="640080" y="4937760"/>
+            <a:off x="640080" y="4983480"/>
             <a:ext cx="118872" cy="118872"/>
           </a:xfrm>
           <a:prstGeom prst="ellipse">
@@ -12651,8 +12699,8 @@
         </p:nvSpPr>
         <p:spPr>
           <a:xfrm>
-            <a:off x="859536" y="4892040"/>
-            <a:ext cx="2448458" cy="256032"/>
+            <a:off x="877824" y="4937760"/>
+            <a:ext cx="3809848" cy="274320"/>
           </a:xfrm>
           <a:prstGeom prst="rect">
             <a:avLst/>
@@ -12668,7 +12716,7 @@
               <a:buNone/>
             </a:pPr>
             <a:r>
-              <a:rPr lang="en-US" sz="1100" dirty="0">
+              <a:rPr lang="en-US" sz="1200" dirty="0">
                 <a:solidFill>
                   <a:srgbClr val="A9B7C9"/>
                 </a:solidFill>
@@ -12678,7 +12726,7 @@
               </a:rPr>
               <a:t>Product &amp; team</a:t>
             </a:r>
-            <a:endParaRPr lang="en-US" sz="1100" dirty="0"/>
+            <a:endParaRPr lang="en-US" sz="1200" dirty="0"/>
           </a:p>
         </p:txBody>
       </p:sp>
@@ -12690,8 +12738,8 @@
         </p:nvSpPr>
         <p:spPr>
           <a:xfrm>
-            <a:off x="3317138" y="4892040"/>
-            <a:ext cx="960120" cy="256032"/>
+            <a:off x="4769968" y="4937760"/>
+            <a:ext cx="1051560" cy="274320"/>
           </a:xfrm>
           <a:prstGeom prst="rect">
             <a:avLst/>
@@ -12707,7 +12755,7 @@
               <a:buNone/>
             </a:pPr>
             <a:r>
-              <a:rPr lang="en-US" sz="1100" b="1" dirty="0">
+              <a:rPr lang="en-US" sz="1200" b="1" dirty="0">
                 <a:solidFill>
                   <a:srgbClr val="F4F7FB"/>
                 </a:solidFill>
@@ -12717,7 +12765,7 @@
               </a:rPr>
               <a:t>Rp2,75 M</a:t>
             </a:r>
-            <a:endParaRPr lang="en-US" sz="1100" dirty="0"/>
+            <a:endParaRPr lang="en-US" sz="1200" dirty="0"/>
           </a:p>
         </p:txBody>
       </p:sp>
@@ -12729,7 +12777,7 @@
         </p:nvSpPr>
         <p:spPr>
           <a:xfrm>
-            <a:off x="4277258" y="4937760"/>
+            <a:off x="6370168" y="4983480"/>
             <a:ext cx="118872" cy="118872"/>
           </a:xfrm>
           <a:prstGeom prst="ellipse">
@@ -12749,8 +12797,8 @@
         </p:nvSpPr>
         <p:spPr>
           <a:xfrm>
-            <a:off x="4496714" y="4892040"/>
-            <a:ext cx="2448458" cy="256032"/>
+            <a:off x="6607912" y="4937760"/>
+            <a:ext cx="3809848" cy="274320"/>
           </a:xfrm>
           <a:prstGeom prst="rect">
             <a:avLst/>
@@ -12766,7 +12814,7 @@
               <a:buNone/>
             </a:pPr>
             <a:r>
-              <a:rPr lang="en-US" sz="1100" dirty="0">
+              <a:rPr lang="en-US" sz="1200" dirty="0">
                 <a:solidFill>
                   <a:srgbClr val="A9B7C9"/>
                 </a:solidFill>
@@ -12776,7 +12824,7 @@
               </a:rPr>
               <a:t>Infra, security, reliability</a:t>
             </a:r>
-            <a:endParaRPr lang="en-US" sz="1100" dirty="0"/>
+            <a:endParaRPr lang="en-US" sz="1200" dirty="0"/>
           </a:p>
         </p:txBody>
       </p:sp>
@@ -12788,8 +12836,8 @@
         </p:nvSpPr>
         <p:spPr>
           <a:xfrm>
-            <a:off x="6954317" y="4892040"/>
-            <a:ext cx="960120" cy="256032"/>
+            <a:off x="10500055" y="4937760"/>
+            <a:ext cx="1051560" cy="274320"/>
           </a:xfrm>
           <a:prstGeom prst="rect">
             <a:avLst/>
@@ -12805,7 +12853,7 @@
               <a:buNone/>
             </a:pPr>
             <a:r>
-              <a:rPr lang="en-US" sz="1100" b="1" dirty="0">
+              <a:rPr lang="en-US" sz="1200" b="1" dirty="0">
                 <a:solidFill>
                   <a:srgbClr val="F4F7FB"/>
                 </a:solidFill>
@@ -12815,7 +12863,7 @@
               </a:rPr>
               <a:t>Rp0,88 M</a:t>
             </a:r>
-            <a:endParaRPr lang="en-US" sz="1100" dirty="0"/>
+            <a:endParaRPr lang="en-US" sz="1200" dirty="0"/>
           </a:p>
         </p:txBody>
       </p:sp>
@@ -12827,7 +12875,7 @@
         </p:nvSpPr>
         <p:spPr>
           <a:xfrm>
-            <a:off x="7914437" y="4937760"/>
+            <a:off x="640080" y="5404104"/>
             <a:ext cx="118872" cy="118872"/>
           </a:xfrm>
           <a:prstGeom prst="ellipse">
@@ -12847,8 +12895,8 @@
         </p:nvSpPr>
         <p:spPr>
           <a:xfrm>
-            <a:off x="8133893" y="4892040"/>
-            <a:ext cx="2448458" cy="256032"/>
+            <a:off x="877824" y="5358384"/>
+            <a:ext cx="3809848" cy="274320"/>
           </a:xfrm>
           <a:prstGeom prst="rect">
             <a:avLst/>
@@ -12864,7 +12912,7 @@
               <a:buNone/>
             </a:pPr>
             <a:r>
-              <a:rPr lang="en-US" sz="1100" dirty="0">
+              <a:rPr lang="en-US" sz="1200" dirty="0">
                 <a:solidFill>
                   <a:srgbClr val="A9B7C9"/>
                 </a:solidFill>
@@ -12874,7 +12922,7 @@
               </a:rPr>
               <a:t>Sales &amp; customer success</a:t>
             </a:r>
-            <a:endParaRPr lang="en-US" sz="1100" dirty="0"/>
+            <a:endParaRPr lang="en-US" sz="1200" dirty="0"/>
           </a:p>
         </p:txBody>
       </p:sp>
@@ -12886,8 +12934,8 @@
         </p:nvSpPr>
         <p:spPr>
           <a:xfrm>
-            <a:off x="10591495" y="4892040"/>
-            <a:ext cx="960120" cy="256032"/>
+            <a:off x="4769968" y="5358384"/>
+            <a:ext cx="1051560" cy="274320"/>
           </a:xfrm>
           <a:prstGeom prst="rect">
             <a:avLst/>
@@ -12903,7 +12951,7 @@
               <a:buNone/>
             </a:pPr>
             <a:r>
-              <a:rPr lang="en-US" sz="1100" b="1" dirty="0">
+              <a:rPr lang="en-US" sz="1200" b="1" dirty="0">
                 <a:solidFill>
                   <a:srgbClr val="F4F7FB"/>
                 </a:solidFill>
@@ -12913,7 +12961,7 @@
               </a:rPr>
               <a:t>Rp0,77 M</a:t>
             </a:r>
-            <a:endParaRPr lang="en-US" sz="1100" dirty="0"/>
+            <a:endParaRPr lang="en-US" sz="1200" dirty="0"/>
           </a:p>
         </p:txBody>
       </p:sp>
@@ -12925,7 +12973,7 @@
         </p:nvSpPr>
         <p:spPr>
           <a:xfrm>
-            <a:off x="640080" y="5303520"/>
+            <a:off x="6370168" y="5404104"/>
             <a:ext cx="118872" cy="118872"/>
           </a:xfrm>
           <a:prstGeom prst="ellipse">
@@ -12945,8 +12993,8 @@
         </p:nvSpPr>
         <p:spPr>
           <a:xfrm>
-            <a:off x="859536" y="5257800"/>
-            <a:ext cx="2448458" cy="256032"/>
+            <a:off x="6607912" y="5358384"/>
+            <a:ext cx="3809848" cy="274320"/>
           </a:xfrm>
           <a:prstGeom prst="rect">
             <a:avLst/>
@@ -12962,7 +13010,7 @@
               <a:buNone/>
             </a:pPr>
             <a:r>
-              <a:rPr lang="en-US" sz="1100" dirty="0">
+              <a:rPr lang="en-US" sz="1200" dirty="0">
                 <a:solidFill>
                   <a:srgbClr val="A9B7C9"/>
                 </a:solidFill>
@@ -12972,7 +13020,7 @@
               </a:rPr>
               <a:t>Legal, compliance, operations</a:t>
             </a:r>
-            <a:endParaRPr lang="en-US" sz="1100" dirty="0"/>
+            <a:endParaRPr lang="en-US" sz="1200" dirty="0"/>
           </a:p>
         </p:txBody>
       </p:sp>
@@ -12984,8 +13032,8 @@
         </p:nvSpPr>
         <p:spPr>
           <a:xfrm>
-            <a:off x="3317138" y="5257800"/>
-            <a:ext cx="960120" cy="256032"/>
+            <a:off x="10500055" y="5358384"/>
+            <a:ext cx="1051560" cy="274320"/>
           </a:xfrm>
           <a:prstGeom prst="rect">
             <a:avLst/>
@@ -13001,7 +13049,7 @@
               <a:buNone/>
             </a:pPr>
             <a:r>
-              <a:rPr lang="en-US" sz="1100" b="1" dirty="0">
+              <a:rPr lang="en-US" sz="1200" b="1" dirty="0">
                 <a:solidFill>
                   <a:srgbClr val="F4F7FB"/>
                 </a:solidFill>
@@ -13011,7 +13059,7 @@
               </a:rPr>
               <a:t>Rp0,55 M</a:t>
             </a:r>
-            <a:endParaRPr lang="en-US" sz="1100" dirty="0"/>
+            <a:endParaRPr lang="en-US" sz="1200" dirty="0"/>
           </a:p>
         </p:txBody>
       </p:sp>
@@ -13023,7 +13071,7 @@
         </p:nvSpPr>
         <p:spPr>
           <a:xfrm>
-            <a:off x="4277258" y="5303520"/>
+            <a:off x="640080" y="5824728"/>
             <a:ext cx="118872" cy="118872"/>
           </a:xfrm>
           <a:prstGeom prst="ellipse">
@@ -13043,8 +13091,8 @@
         </p:nvSpPr>
         <p:spPr>
           <a:xfrm>
-            <a:off x="4496714" y="5257800"/>
-            <a:ext cx="2448458" cy="256032"/>
+            <a:off x="877824" y="5779008"/>
+            <a:ext cx="3809848" cy="274320"/>
           </a:xfrm>
           <a:prstGeom prst="rect">
             <a:avLst/>
@@ -13060,7 +13108,7 @@
               <a:buNone/>
             </a:pPr>
             <a:r>
-              <a:rPr lang="en-US" sz="1100" dirty="0">
+              <a:rPr lang="en-US" sz="1200" dirty="0">
                 <a:solidFill>
                   <a:srgbClr val="A9B7C9"/>
                 </a:solidFill>
@@ -13070,7 +13118,7 @@
               </a:rPr>
               <a:t>Contingency</a:t>
             </a:r>
-            <a:endParaRPr lang="en-US" sz="1100" dirty="0"/>
+            <a:endParaRPr lang="en-US" sz="1200" dirty="0"/>
           </a:p>
         </p:txBody>
       </p:sp>
@@ -13082,8 +13130,8 @@
         </p:nvSpPr>
         <p:spPr>
           <a:xfrm>
-            <a:off x="6954317" y="5257800"/>
-            <a:ext cx="960120" cy="256032"/>
+            <a:off x="4769968" y="5779008"/>
+            <a:ext cx="1051560" cy="274320"/>
           </a:xfrm>
           <a:prstGeom prst="rect">
             <a:avLst/>
@@ -13099,7 +13147,7 @@
               <a:buNone/>
             </a:pPr>
             <a:r>
-              <a:rPr lang="en-US" sz="1100" b="1" dirty="0">
+              <a:rPr lang="en-US" sz="1200" b="1" dirty="0">
                 <a:solidFill>
                   <a:srgbClr val="F4F7FB"/>
                 </a:solidFill>
@@ -13109,7 +13157,7 @@
               </a:rPr>
               <a:t>Rp0,55 M</a:t>
             </a:r>
-            <a:endParaRPr lang="en-US" sz="1100" dirty="0"/>
+            <a:endParaRPr lang="en-US" sz="1200" dirty="0"/>
           </a:p>
         </p:txBody>
       </p:sp>
@@ -15694,15 +15742,31 @@
           <a:bodyPr wrap="square" lIns="0" tIns="0" rIns="0" bIns="0" rtlCol="0" anchor="t"/>
           <a:lstStyle/>
           <a:p>
-            <a:pPr marL="228600" indent="-228600">
+            <a:pPr indent="0" marL="0">
+              <a:lnSpc>
+                <a:spcPct val="120000"/>
+              </a:lnSpc>
+              <a:buNone/>
+            </a:pPr>
+            <a:r>
+              <a:rPr lang="en-US" sz="1400" dirty="0">
+                <a:solidFill>
+                  <a:srgbClr val="58D6C7"/>
+                </a:solidFill>
+                <a:latin typeface="Calibri" pitchFamily="34" charset="0"/>
+                <a:ea typeface="Calibri" pitchFamily="34" charset="-122"/>
+                <a:cs typeface="Calibri" pitchFamily="34" charset="-120"/>
+              </a:rPr>
+              <a:t>●  </a:t>
+            </a:r>
+            <a:pPr indent="0" marL="0">
               <a:lnSpc>
                 <a:spcPct val="120000"/>
               </a:lnSpc>
               <a:spcAft>
                 <a:spcPts val="1600"/>
               </a:spcAft>
-              <a:buSzPct val="100000"/>
-              <a:buChar char="●"/>
+              <a:buNone/>
             </a:pPr>
             <a:r>
               <a:rPr lang="en-US" sz="1400" dirty="0">
@@ -15718,15 +15782,31 @@
             <a:endParaRPr lang="en-US" sz="1400" dirty="0"/>
           </a:p>
           <a:p>
-            <a:pPr marL="228600" indent="-228600">
+            <a:pPr indent="0" marL="0">
+              <a:lnSpc>
+                <a:spcPct val="120000"/>
+              </a:lnSpc>
+              <a:buNone/>
+            </a:pPr>
+            <a:r>
+              <a:rPr lang="en-US" sz="1400" dirty="0">
+                <a:solidFill>
+                  <a:srgbClr val="58D6C7"/>
+                </a:solidFill>
+                <a:latin typeface="Calibri" pitchFamily="34" charset="0"/>
+                <a:ea typeface="Calibri" pitchFamily="34" charset="-122"/>
+                <a:cs typeface="Calibri" pitchFamily="34" charset="-120"/>
+              </a:rPr>
+              <a:t>●  </a:t>
+            </a:r>
+            <a:pPr indent="0" marL="0">
               <a:lnSpc>
                 <a:spcPct val="120000"/>
               </a:lnSpc>
               <a:spcAft>
                 <a:spcPts val="1600"/>
               </a:spcAft>
-              <a:buSzPct val="100000"/>
-              <a:buChar char="●"/>
+              <a:buNone/>
             </a:pPr>
             <a:r>
               <a:rPr lang="en-US" sz="1400" dirty="0">
@@ -15742,15 +15822,31 @@
             <a:endParaRPr lang="en-US" sz="1400" dirty="0"/>
           </a:p>
           <a:p>
-            <a:pPr marL="228600" indent="-228600">
+            <a:pPr indent="0" marL="0">
+              <a:lnSpc>
+                <a:spcPct val="120000"/>
+              </a:lnSpc>
+              <a:buNone/>
+            </a:pPr>
+            <a:r>
+              <a:rPr lang="en-US" sz="1400" dirty="0">
+                <a:solidFill>
+                  <a:srgbClr val="58D6C7"/>
+                </a:solidFill>
+                <a:latin typeface="Calibri" pitchFamily="34" charset="0"/>
+                <a:ea typeface="Calibri" pitchFamily="34" charset="-122"/>
+                <a:cs typeface="Calibri" pitchFamily="34" charset="-120"/>
+              </a:rPr>
+              <a:t>●  </a:t>
+            </a:r>
+            <a:pPr indent="0" marL="0">
               <a:lnSpc>
                 <a:spcPct val="120000"/>
               </a:lnSpc>
               <a:spcAft>
                 <a:spcPts val="1600"/>
               </a:spcAft>
-              <a:buSzPct val="100000"/>
-              <a:buChar char="●"/>
+              <a:buNone/>
             </a:pPr>
             <a:r>
               <a:rPr lang="en-US" sz="1400" dirty="0">
@@ -15766,15 +15862,31 @@
             <a:endParaRPr lang="en-US" sz="1400" dirty="0"/>
           </a:p>
           <a:p>
-            <a:pPr marL="228600" indent="-228600">
+            <a:pPr indent="0" marL="0">
+              <a:lnSpc>
+                <a:spcPct val="120000"/>
+              </a:lnSpc>
+              <a:buNone/>
+            </a:pPr>
+            <a:r>
+              <a:rPr lang="en-US" sz="1400" dirty="0">
+                <a:solidFill>
+                  <a:srgbClr val="58D6C7"/>
+                </a:solidFill>
+                <a:latin typeface="Calibri" pitchFamily="34" charset="0"/>
+                <a:ea typeface="Calibri" pitchFamily="34" charset="-122"/>
+                <a:cs typeface="Calibri" pitchFamily="34" charset="-120"/>
+              </a:rPr>
+              <a:t>●  </a:t>
+            </a:r>
+            <a:pPr indent="0" marL="0">
               <a:lnSpc>
                 <a:spcPct val="120000"/>
               </a:lnSpc>
               <a:spcAft>
                 <a:spcPts val="1600"/>
               </a:spcAft>
-              <a:buSzPct val="100000"/>
-              <a:buChar char="●"/>
+              <a:buNone/>
             </a:pPr>
             <a:r>
               <a:rPr lang="en-US" sz="1400" dirty="0">
@@ -16158,10 +16270,10 @@
         </p:nvSpPr>
         <p:spPr>
           <a:xfrm>
-            <a:off x="1020928" y="2423160"/>
-            <a:ext cx="2926080" cy="54864"/>
-          </a:xfrm>
-          <a:prstGeom prst="roundRect">
+            <a:off x="1249528" y="2651760"/>
+            <a:ext cx="146304" cy="146304"/>
+          </a:xfrm>
+          <a:prstGeom prst="ellipse">
             <a:avLst/>
           </a:prstGeom>
           <a:solidFill>
@@ -16178,8 +16290,8 @@
         </p:nvSpPr>
         <p:spPr>
           <a:xfrm>
-            <a:off x="1249528" y="2679192"/>
-            <a:ext cx="2468880" cy="411480"/>
+            <a:off x="1523848" y="2569464"/>
+            <a:ext cx="2194560" cy="365760"/>
           </a:xfrm>
           <a:prstGeom prst="rect">
             <a:avLst/>
@@ -16217,8 +16329,8 @@
         </p:nvSpPr>
         <p:spPr>
           <a:xfrm>
-            <a:off x="1249528" y="3108960"/>
-            <a:ext cx="2468880" cy="594360"/>
+            <a:off x="1249528" y="3081528"/>
+            <a:ext cx="2468880" cy="621792"/>
           </a:xfrm>
           <a:prstGeom prst="rect">
             <a:avLst/>
@@ -16320,10 +16432,10 @@
         </p:nvSpPr>
         <p:spPr>
           <a:xfrm>
-            <a:off x="4632808" y="2423160"/>
-            <a:ext cx="2926080" cy="54864"/>
-          </a:xfrm>
-          <a:prstGeom prst="roundRect">
+            <a:off x="4861408" y="2651760"/>
+            <a:ext cx="146304" cy="146304"/>
+          </a:xfrm>
+          <a:prstGeom prst="ellipse">
             <a:avLst/>
           </a:prstGeom>
           <a:solidFill>
@@ -16340,8 +16452,8 @@
         </p:nvSpPr>
         <p:spPr>
           <a:xfrm>
-            <a:off x="4861408" y="2679192"/>
-            <a:ext cx="2468880" cy="411480"/>
+            <a:off x="5135728" y="2569464"/>
+            <a:ext cx="2194560" cy="365760"/>
           </a:xfrm>
           <a:prstGeom prst="rect">
             <a:avLst/>
@@ -16379,8 +16491,8 @@
         </p:nvSpPr>
         <p:spPr>
           <a:xfrm>
-            <a:off x="4861408" y="3108960"/>
-            <a:ext cx="2468880" cy="594360"/>
+            <a:off x="4861408" y="3081528"/>
+            <a:ext cx="2468880" cy="621792"/>
           </a:xfrm>
           <a:prstGeom prst="rect">
             <a:avLst/>
@@ -16482,10 +16594,10 @@
         </p:nvSpPr>
         <p:spPr>
           <a:xfrm>
-            <a:off x="8244688" y="2423160"/>
-            <a:ext cx="2926080" cy="54864"/>
-          </a:xfrm>
-          <a:prstGeom prst="roundRect">
+            <a:off x="8473288" y="2651760"/>
+            <a:ext cx="146304" cy="146304"/>
+          </a:xfrm>
+          <a:prstGeom prst="ellipse">
             <a:avLst/>
           </a:prstGeom>
           <a:solidFill>
@@ -16502,8 +16614,8 @@
         </p:nvSpPr>
         <p:spPr>
           <a:xfrm>
-            <a:off x="8473288" y="2679192"/>
-            <a:ext cx="2468880" cy="411480"/>
+            <a:off x="8747608" y="2569464"/>
+            <a:ext cx="2194560" cy="365760"/>
           </a:xfrm>
           <a:prstGeom prst="rect">
             <a:avLst/>
@@ -16541,8 +16653,8 @@
         </p:nvSpPr>
         <p:spPr>
           <a:xfrm>
-            <a:off x="8473288" y="3108960"/>
-            <a:ext cx="2468880" cy="594360"/>
+            <a:off x="8473288" y="3081528"/>
+            <a:ext cx="2468880" cy="621792"/>
           </a:xfrm>
           <a:prstGeom prst="rect">
             <a:avLst/>
@@ -17202,15 +17314,31 @@
           <a:bodyPr wrap="square" lIns="0" tIns="0" rIns="0" bIns="0" rtlCol="0" anchor="t"/>
           <a:lstStyle/>
           <a:p>
-            <a:pPr marL="228600" indent="-228600">
+            <a:pPr indent="0" marL="0">
+              <a:lnSpc>
+                <a:spcPct val="120000"/>
+              </a:lnSpc>
+              <a:buNone/>
+            </a:pPr>
+            <a:r>
+              <a:rPr lang="en-US" sz="1150" dirty="0">
+                <a:solidFill>
+                  <a:srgbClr val="58D6C7"/>
+                </a:solidFill>
+                <a:latin typeface="Calibri" pitchFamily="34" charset="0"/>
+                <a:ea typeface="Calibri" pitchFamily="34" charset="-122"/>
+                <a:cs typeface="Calibri" pitchFamily="34" charset="-120"/>
+              </a:rPr>
+              <a:t>●  </a:t>
+            </a:r>
+            <a:pPr indent="0" marL="0">
               <a:lnSpc>
                 <a:spcPct val="120000"/>
               </a:lnSpc>
               <a:spcAft>
                 <a:spcPts val="600"/>
               </a:spcAft>
-              <a:buSzPct val="100000"/>
-              <a:buChar char="●"/>
+              <a:buNone/>
             </a:pPr>
             <a:r>
               <a:rPr lang="en-US" sz="1150" dirty="0">
@@ -17226,15 +17354,31 @@
             <a:endParaRPr lang="en-US" sz="1150" dirty="0"/>
           </a:p>
           <a:p>
-            <a:pPr marL="228600" indent="-228600">
+            <a:pPr indent="0" marL="0">
+              <a:lnSpc>
+                <a:spcPct val="120000"/>
+              </a:lnSpc>
+              <a:buNone/>
+            </a:pPr>
+            <a:r>
+              <a:rPr lang="en-US" sz="1150" dirty="0">
+                <a:solidFill>
+                  <a:srgbClr val="58D6C7"/>
+                </a:solidFill>
+                <a:latin typeface="Calibri" pitchFamily="34" charset="0"/>
+                <a:ea typeface="Calibri" pitchFamily="34" charset="-122"/>
+                <a:cs typeface="Calibri" pitchFamily="34" charset="-120"/>
+              </a:rPr>
+              <a:t>●  </a:t>
+            </a:r>
+            <a:pPr indent="0" marL="0">
               <a:lnSpc>
                 <a:spcPct val="120000"/>
               </a:lnSpc>
               <a:spcAft>
                 <a:spcPts val="600"/>
               </a:spcAft>
-              <a:buSzPct val="100000"/>
-              <a:buChar char="●"/>
+              <a:buNone/>
             </a:pPr>
             <a:r>
               <a:rPr lang="en-US" sz="1150" dirty="0">
@@ -17250,15 +17394,31 @@
             <a:endParaRPr lang="en-US" sz="1150" dirty="0"/>
           </a:p>
           <a:p>
-            <a:pPr marL="228600" indent="-228600">
+            <a:pPr indent="0" marL="0">
+              <a:lnSpc>
+                <a:spcPct val="120000"/>
+              </a:lnSpc>
+              <a:buNone/>
+            </a:pPr>
+            <a:r>
+              <a:rPr lang="en-US" sz="1150" dirty="0">
+                <a:solidFill>
+                  <a:srgbClr val="58D6C7"/>
+                </a:solidFill>
+                <a:latin typeface="Calibri" pitchFamily="34" charset="0"/>
+                <a:ea typeface="Calibri" pitchFamily="34" charset="-122"/>
+                <a:cs typeface="Calibri" pitchFamily="34" charset="-120"/>
+              </a:rPr>
+              <a:t>●  </a:t>
+            </a:r>
+            <a:pPr indent="0" marL="0">
               <a:lnSpc>
                 <a:spcPct val="120000"/>
               </a:lnSpc>
               <a:spcAft>
                 <a:spcPts val="600"/>
               </a:spcAft>
-              <a:buSzPct val="100000"/>
-              <a:buChar char="●"/>
+              <a:buNone/>
             </a:pPr>
             <a:r>
               <a:rPr lang="en-US" sz="1150" dirty="0">
@@ -17399,15 +17559,31 @@
           <a:bodyPr wrap="square" lIns="0" tIns="0" rIns="0" bIns="0" rtlCol="0" anchor="t"/>
           <a:lstStyle/>
           <a:p>
-            <a:pPr marL="228600" indent="-228600">
+            <a:pPr indent="0" marL="0">
+              <a:lnSpc>
+                <a:spcPct val="120000"/>
+              </a:lnSpc>
+              <a:buNone/>
+            </a:pPr>
+            <a:r>
+              <a:rPr lang="en-US" sz="1150" dirty="0">
+                <a:solidFill>
+                  <a:srgbClr val="FFB25B"/>
+                </a:solidFill>
+                <a:latin typeface="Calibri" pitchFamily="34" charset="0"/>
+                <a:ea typeface="Calibri" pitchFamily="34" charset="-122"/>
+                <a:cs typeface="Calibri" pitchFamily="34" charset="-120"/>
+              </a:rPr>
+              <a:t>●  </a:t>
+            </a:r>
+            <a:pPr indent="0" marL="0">
               <a:lnSpc>
                 <a:spcPct val="120000"/>
               </a:lnSpc>
               <a:spcAft>
                 <a:spcPts val="600"/>
               </a:spcAft>
-              <a:buSzPct val="100000"/>
-              <a:buChar char="●"/>
+              <a:buNone/>
             </a:pPr>
             <a:r>
               <a:rPr lang="en-US" sz="1150" dirty="0">
@@ -17423,15 +17599,31 @@
             <a:endParaRPr lang="en-US" sz="1150" dirty="0"/>
           </a:p>
           <a:p>
-            <a:pPr marL="228600" indent="-228600">
+            <a:pPr indent="0" marL="0">
+              <a:lnSpc>
+                <a:spcPct val="120000"/>
+              </a:lnSpc>
+              <a:buNone/>
+            </a:pPr>
+            <a:r>
+              <a:rPr lang="en-US" sz="1150" dirty="0">
+                <a:solidFill>
+                  <a:srgbClr val="FFB25B"/>
+                </a:solidFill>
+                <a:latin typeface="Calibri" pitchFamily="34" charset="0"/>
+                <a:ea typeface="Calibri" pitchFamily="34" charset="-122"/>
+                <a:cs typeface="Calibri" pitchFamily="34" charset="-120"/>
+              </a:rPr>
+              <a:t>●  </a:t>
+            </a:r>
+            <a:pPr indent="0" marL="0">
               <a:lnSpc>
                 <a:spcPct val="120000"/>
               </a:lnSpc>
               <a:spcAft>
                 <a:spcPts val="600"/>
               </a:spcAft>
-              <a:buSzPct val="100000"/>
-              <a:buChar char="●"/>
+              <a:buNone/>
             </a:pPr>
             <a:r>
               <a:rPr lang="en-US" sz="1150" dirty="0">
@@ -17447,15 +17639,31 @@
             <a:endParaRPr lang="en-US" sz="1150" dirty="0"/>
           </a:p>
           <a:p>
-            <a:pPr marL="228600" indent="-228600">
+            <a:pPr indent="0" marL="0">
+              <a:lnSpc>
+                <a:spcPct val="120000"/>
+              </a:lnSpc>
+              <a:buNone/>
+            </a:pPr>
+            <a:r>
+              <a:rPr lang="en-US" sz="1150" dirty="0">
+                <a:solidFill>
+                  <a:srgbClr val="FFB25B"/>
+                </a:solidFill>
+                <a:latin typeface="Calibri" pitchFamily="34" charset="0"/>
+                <a:ea typeface="Calibri" pitchFamily="34" charset="-122"/>
+                <a:cs typeface="Calibri" pitchFamily="34" charset="-120"/>
+              </a:rPr>
+              <a:t>●  </a:t>
+            </a:r>
+            <a:pPr indent="0" marL="0">
               <a:lnSpc>
                 <a:spcPct val="120000"/>
               </a:lnSpc>
               <a:spcAft>
                 <a:spcPts val="600"/>
               </a:spcAft>
-              <a:buSzPct val="100000"/>
-              <a:buChar char="●"/>
+              <a:buNone/>
             </a:pPr>
             <a:r>
               <a:rPr lang="en-US" sz="1150" dirty="0">
@@ -17951,15 +18159,31 @@
           <a:bodyPr wrap="square" lIns="0" tIns="0" rIns="0" bIns="0" rtlCol="0" anchor="t"/>
           <a:lstStyle/>
           <a:p>
-            <a:pPr marL="228600" indent="-228600">
+            <a:pPr indent="0" marL="0">
+              <a:lnSpc>
+                <a:spcPct val="120000"/>
+              </a:lnSpc>
+              <a:buNone/>
+            </a:pPr>
+            <a:r>
+              <a:rPr lang="en-US" sz="1350" dirty="0">
+                <a:solidFill>
+                  <a:srgbClr val="58D6C7"/>
+                </a:solidFill>
+                <a:latin typeface="Calibri" pitchFamily="34" charset="0"/>
+                <a:ea typeface="Calibri" pitchFamily="34" charset="-122"/>
+                <a:cs typeface="Calibri" pitchFamily="34" charset="-120"/>
+              </a:rPr>
+              <a:t>●  </a:t>
+            </a:r>
+            <a:pPr indent="0" marL="0">
               <a:lnSpc>
                 <a:spcPct val="120000"/>
               </a:lnSpc>
               <a:spcAft>
                 <a:spcPts val="1300"/>
               </a:spcAft>
-              <a:buSzPct val="100000"/>
-              <a:buChar char="●"/>
+              <a:buNone/>
             </a:pPr>
             <a:r>
               <a:rPr lang="en-US" sz="1350" dirty="0">
@@ -17975,15 +18199,31 @@
             <a:endParaRPr lang="en-US" sz="1350" dirty="0"/>
           </a:p>
           <a:p>
-            <a:pPr marL="228600" indent="-228600">
+            <a:pPr indent="0" marL="0">
+              <a:lnSpc>
+                <a:spcPct val="120000"/>
+              </a:lnSpc>
+              <a:buNone/>
+            </a:pPr>
+            <a:r>
+              <a:rPr lang="en-US" sz="1350" dirty="0">
+                <a:solidFill>
+                  <a:srgbClr val="58D6C7"/>
+                </a:solidFill>
+                <a:latin typeface="Calibri" pitchFamily="34" charset="0"/>
+                <a:ea typeface="Calibri" pitchFamily="34" charset="-122"/>
+                <a:cs typeface="Calibri" pitchFamily="34" charset="-120"/>
+              </a:rPr>
+              <a:t>●  </a:t>
+            </a:r>
+            <a:pPr indent="0" marL="0">
               <a:lnSpc>
                 <a:spcPct val="120000"/>
               </a:lnSpc>
               <a:spcAft>
                 <a:spcPts val="1300"/>
               </a:spcAft>
-              <a:buSzPct val="100000"/>
-              <a:buChar char="●"/>
+              <a:buNone/>
             </a:pPr>
             <a:r>
               <a:rPr lang="en-US" sz="1350" dirty="0">
@@ -17999,15 +18239,31 @@
             <a:endParaRPr lang="en-US" sz="1350" dirty="0"/>
           </a:p>
           <a:p>
-            <a:pPr marL="228600" indent="-228600">
+            <a:pPr indent="0" marL="0">
+              <a:lnSpc>
+                <a:spcPct val="120000"/>
+              </a:lnSpc>
+              <a:buNone/>
+            </a:pPr>
+            <a:r>
+              <a:rPr lang="en-US" sz="1350" dirty="0">
+                <a:solidFill>
+                  <a:srgbClr val="58D6C7"/>
+                </a:solidFill>
+                <a:latin typeface="Calibri" pitchFamily="34" charset="0"/>
+                <a:ea typeface="Calibri" pitchFamily="34" charset="-122"/>
+                <a:cs typeface="Calibri" pitchFamily="34" charset="-120"/>
+              </a:rPr>
+              <a:t>●  </a:t>
+            </a:r>
+            <a:pPr indent="0" marL="0">
               <a:lnSpc>
                 <a:spcPct val="120000"/>
               </a:lnSpc>
               <a:spcAft>
                 <a:spcPts val="1300"/>
               </a:spcAft>
-              <a:buSzPct val="100000"/>
-              <a:buChar char="●"/>
+              <a:buNone/>
             </a:pPr>
             <a:r>
               <a:rPr lang="en-US" sz="1350" dirty="0">
@@ -18023,15 +18279,31 @@
             <a:endParaRPr lang="en-US" sz="1350" dirty="0"/>
           </a:p>
           <a:p>
-            <a:pPr marL="228600" indent="-228600">
+            <a:pPr indent="0" marL="0">
+              <a:lnSpc>
+                <a:spcPct val="120000"/>
+              </a:lnSpc>
+              <a:buNone/>
+            </a:pPr>
+            <a:r>
+              <a:rPr lang="en-US" sz="1350" dirty="0">
+                <a:solidFill>
+                  <a:srgbClr val="58D6C7"/>
+                </a:solidFill>
+                <a:latin typeface="Calibri" pitchFamily="34" charset="0"/>
+                <a:ea typeface="Calibri" pitchFamily="34" charset="-122"/>
+                <a:cs typeface="Calibri" pitchFamily="34" charset="-120"/>
+              </a:rPr>
+              <a:t>●  </a:t>
+            </a:r>
+            <a:pPr indent="0" marL="0">
               <a:lnSpc>
                 <a:spcPct val="120000"/>
               </a:lnSpc>
               <a:spcAft>
                 <a:spcPts val="1300"/>
               </a:spcAft>
-              <a:buSzPct val="100000"/>
-              <a:buChar char="●"/>
+              <a:buNone/>
             </a:pPr>
             <a:r>
               <a:rPr lang="en-US" sz="1350" dirty="0">
@@ -18047,15 +18319,31 @@
             <a:endParaRPr lang="en-US" sz="1350" dirty="0"/>
           </a:p>
           <a:p>
-            <a:pPr marL="228600" indent="-228600">
+            <a:pPr indent="0" marL="0">
+              <a:lnSpc>
+                <a:spcPct val="120000"/>
+              </a:lnSpc>
+              <a:buNone/>
+            </a:pPr>
+            <a:r>
+              <a:rPr lang="en-US" sz="1350" dirty="0">
+                <a:solidFill>
+                  <a:srgbClr val="58D6C7"/>
+                </a:solidFill>
+                <a:latin typeface="Calibri" pitchFamily="34" charset="0"/>
+                <a:ea typeface="Calibri" pitchFamily="34" charset="-122"/>
+                <a:cs typeface="Calibri" pitchFamily="34" charset="-120"/>
+              </a:rPr>
+              <a:t>●  </a:t>
+            </a:r>
+            <a:pPr indent="0" marL="0">
               <a:lnSpc>
                 <a:spcPct val="120000"/>
               </a:lnSpc>
               <a:spcAft>
                 <a:spcPts val="1300"/>
               </a:spcAft>
-              <a:buSzPct val="100000"/>
-              <a:buChar char="●"/>
+              <a:buNone/>
             </a:pPr>
             <a:r>
               <a:rPr lang="en-US" sz="1350" dirty="0">
@@ -18071,15 +18359,31 @@
             <a:endParaRPr lang="en-US" sz="1350" dirty="0"/>
           </a:p>
           <a:p>
-            <a:pPr marL="228600" indent="-228600">
+            <a:pPr indent="0" marL="0">
+              <a:lnSpc>
+                <a:spcPct val="120000"/>
+              </a:lnSpc>
+              <a:buNone/>
+            </a:pPr>
+            <a:r>
+              <a:rPr lang="en-US" sz="1350" dirty="0">
+                <a:solidFill>
+                  <a:srgbClr val="58D6C7"/>
+                </a:solidFill>
+                <a:latin typeface="Calibri" pitchFamily="34" charset="0"/>
+                <a:ea typeface="Calibri" pitchFamily="34" charset="-122"/>
+                <a:cs typeface="Calibri" pitchFamily="34" charset="-120"/>
+              </a:rPr>
+              <a:t>●  </a:t>
+            </a:r>
+            <a:pPr indent="0" marL="0">
               <a:lnSpc>
                 <a:spcPct val="120000"/>
               </a:lnSpc>
               <a:spcAft>
                 <a:spcPts val="1300"/>
               </a:spcAft>
-              <a:buSzPct val="100000"/>
-              <a:buChar char="●"/>
+              <a:buNone/>
             </a:pPr>
             <a:r>
               <a:rPr lang="en-US" sz="1350" dirty="0">
@@ -18178,15 +18482,31 @@
           <a:bodyPr wrap="square" lIns="0" tIns="0" rIns="0" bIns="0" rtlCol="0" anchor="t"/>
           <a:lstStyle/>
           <a:p>
-            <a:pPr marL="228600" indent="-228600">
+            <a:pPr indent="0" marL="0">
+              <a:lnSpc>
+                <a:spcPct val="120000"/>
+              </a:lnSpc>
+              <a:buNone/>
+            </a:pPr>
+            <a:r>
+              <a:rPr lang="en-US" sz="1350" dirty="0">
+                <a:solidFill>
+                  <a:srgbClr val="FF9088"/>
+                </a:solidFill>
+                <a:latin typeface="Calibri" pitchFamily="34" charset="0"/>
+                <a:ea typeface="Calibri" pitchFamily="34" charset="-122"/>
+                <a:cs typeface="Calibri" pitchFamily="34" charset="-120"/>
+              </a:rPr>
+              <a:t>●  </a:t>
+            </a:r>
+            <a:pPr indent="0" marL="0">
               <a:lnSpc>
                 <a:spcPct val="120000"/>
               </a:lnSpc>
               <a:spcAft>
                 <a:spcPts val="1300"/>
               </a:spcAft>
-              <a:buSzPct val="100000"/>
-              <a:buChar char="●"/>
+              <a:buNone/>
             </a:pPr>
             <a:r>
               <a:rPr lang="en-US" sz="1350" dirty="0">
@@ -18202,15 +18522,31 @@
             <a:endParaRPr lang="en-US" sz="1350" dirty="0"/>
           </a:p>
           <a:p>
-            <a:pPr marL="228600" indent="-228600">
+            <a:pPr indent="0" marL="0">
+              <a:lnSpc>
+                <a:spcPct val="120000"/>
+              </a:lnSpc>
+              <a:buNone/>
+            </a:pPr>
+            <a:r>
+              <a:rPr lang="en-US" sz="1350" dirty="0">
+                <a:solidFill>
+                  <a:srgbClr val="FF9088"/>
+                </a:solidFill>
+                <a:latin typeface="Calibri" pitchFamily="34" charset="0"/>
+                <a:ea typeface="Calibri" pitchFamily="34" charset="-122"/>
+                <a:cs typeface="Calibri" pitchFamily="34" charset="-120"/>
+              </a:rPr>
+              <a:t>●  </a:t>
+            </a:r>
+            <a:pPr indent="0" marL="0">
               <a:lnSpc>
                 <a:spcPct val="120000"/>
               </a:lnSpc>
               <a:spcAft>
                 <a:spcPts val="1300"/>
               </a:spcAft>
-              <a:buSzPct val="100000"/>
-              <a:buChar char="●"/>
+              <a:buNone/>
             </a:pPr>
             <a:r>
               <a:rPr lang="en-US" sz="1350" dirty="0">
@@ -18226,15 +18562,31 @@
             <a:endParaRPr lang="en-US" sz="1350" dirty="0"/>
           </a:p>
           <a:p>
-            <a:pPr marL="228600" indent="-228600">
+            <a:pPr indent="0" marL="0">
+              <a:lnSpc>
+                <a:spcPct val="120000"/>
+              </a:lnSpc>
+              <a:buNone/>
+            </a:pPr>
+            <a:r>
+              <a:rPr lang="en-US" sz="1350" dirty="0">
+                <a:solidFill>
+                  <a:srgbClr val="FF9088"/>
+                </a:solidFill>
+                <a:latin typeface="Calibri" pitchFamily="34" charset="0"/>
+                <a:ea typeface="Calibri" pitchFamily="34" charset="-122"/>
+                <a:cs typeface="Calibri" pitchFamily="34" charset="-120"/>
+              </a:rPr>
+              <a:t>●  </a:t>
+            </a:r>
+            <a:pPr indent="0" marL="0">
               <a:lnSpc>
                 <a:spcPct val="120000"/>
               </a:lnSpc>
               <a:spcAft>
                 <a:spcPts val="1300"/>
               </a:spcAft>
-              <a:buSzPct val="100000"/>
-              <a:buChar char="●"/>
+              <a:buNone/>
             </a:pPr>
             <a:r>
               <a:rPr lang="en-US" sz="1350" dirty="0">
@@ -18250,15 +18602,31 @@
             <a:endParaRPr lang="en-US" sz="1350" dirty="0"/>
           </a:p>
           <a:p>
-            <a:pPr marL="228600" indent="-228600">
+            <a:pPr indent="0" marL="0">
+              <a:lnSpc>
+                <a:spcPct val="120000"/>
+              </a:lnSpc>
+              <a:buNone/>
+            </a:pPr>
+            <a:r>
+              <a:rPr lang="en-US" sz="1350" dirty="0">
+                <a:solidFill>
+                  <a:srgbClr val="FF9088"/>
+                </a:solidFill>
+                <a:latin typeface="Calibri" pitchFamily="34" charset="0"/>
+                <a:ea typeface="Calibri" pitchFamily="34" charset="-122"/>
+                <a:cs typeface="Calibri" pitchFamily="34" charset="-120"/>
+              </a:rPr>
+              <a:t>●  </a:t>
+            </a:r>
+            <a:pPr indent="0" marL="0">
               <a:lnSpc>
                 <a:spcPct val="120000"/>
               </a:lnSpc>
               <a:spcAft>
                 <a:spcPts val="1300"/>
               </a:spcAft>
-              <a:buSzPct val="100000"/>
-              <a:buChar char="●"/>
+              <a:buNone/>
             </a:pPr>
             <a:r>
               <a:rPr lang="en-US" sz="1350" dirty="0">
@@ -18274,15 +18642,31 @@
             <a:endParaRPr lang="en-US" sz="1350" dirty="0"/>
           </a:p>
           <a:p>
-            <a:pPr marL="228600" indent="-228600">
+            <a:pPr indent="0" marL="0">
+              <a:lnSpc>
+                <a:spcPct val="120000"/>
+              </a:lnSpc>
+              <a:buNone/>
+            </a:pPr>
+            <a:r>
+              <a:rPr lang="en-US" sz="1350" dirty="0">
+                <a:solidFill>
+                  <a:srgbClr val="FF9088"/>
+                </a:solidFill>
+                <a:latin typeface="Calibri" pitchFamily="34" charset="0"/>
+                <a:ea typeface="Calibri" pitchFamily="34" charset="-122"/>
+                <a:cs typeface="Calibri" pitchFamily="34" charset="-120"/>
+              </a:rPr>
+              <a:t>●  </a:t>
+            </a:r>
+            <a:pPr indent="0" marL="0">
               <a:lnSpc>
                 <a:spcPct val="120000"/>
               </a:lnSpc>
               <a:spcAft>
                 <a:spcPts val="1300"/>
               </a:spcAft>
-              <a:buSzPct val="100000"/>
-              <a:buChar char="●"/>
+              <a:buNone/>
             </a:pPr>
             <a:r>
               <a:rPr lang="en-US" sz="1350" dirty="0">
@@ -18298,15 +18682,31 @@
             <a:endParaRPr lang="en-US" sz="1350" dirty="0"/>
           </a:p>
           <a:p>
-            <a:pPr marL="228600" indent="-228600">
+            <a:pPr indent="0" marL="0">
+              <a:lnSpc>
+                <a:spcPct val="120000"/>
+              </a:lnSpc>
+              <a:buNone/>
+            </a:pPr>
+            <a:r>
+              <a:rPr lang="en-US" sz="1350" dirty="0">
+                <a:solidFill>
+                  <a:srgbClr val="FF9088"/>
+                </a:solidFill>
+                <a:latin typeface="Calibri" pitchFamily="34" charset="0"/>
+                <a:ea typeface="Calibri" pitchFamily="34" charset="-122"/>
+                <a:cs typeface="Calibri" pitchFamily="34" charset="-120"/>
+              </a:rPr>
+              <a:t>●  </a:t>
+            </a:r>
+            <a:pPr indent="0" marL="0">
               <a:lnSpc>
                 <a:spcPct val="120000"/>
               </a:lnSpc>
               <a:spcAft>
                 <a:spcPts val="1300"/>
               </a:spcAft>
-              <a:buSzPct val="100000"/>
-              <a:buChar char="●"/>
+              <a:buNone/>
             </a:pPr>
             <a:r>
               <a:rPr lang="en-US" sz="1350" dirty="0">

</xml_diff>